<commit_message>
docs: update 2026Q2 PowerPoint presentation
</commit_message>
<xml_diff>
--- a/docs/presentaciones/presentacion_ipa27_26Q2.pptx
+++ b/docs/presentaciones/presentacion_ipa27_26Q2.pptx
@@ -2713,11 +2713,11 @@
           <a:bodyPr wrap="square" lIns="0" tIns="0" rIns="0" bIns="0" rtlCol="0" anchor="ctr"/>
           <a:lstStyle/>
           <a:p>
-            <a:pPr marL="0" indent="0" algn="l">
+            <a:pPr marL="0" indent="0" algn="r">
               <a:buNone/>
             </a:pPr>
             <a:r>
-              <a:rPr lang="en-US" sz="13500" b="1" dirty="0">
+              <a:rPr lang="en-US" sz="11300" b="1" dirty="0">
                 <a:solidFill>
                   <a:srgbClr val="007932"/>
                 </a:solidFill>
@@ -2727,7 +2727,7 @@
               </a:rPr>
               <a:t>IPA27</a:t>
             </a:r>
-            <a:endParaRPr lang="en-US" sz="13500" dirty="0"/>
+            <a:endParaRPr lang="en-US" sz="11300" dirty="0"/>
           </a:p>
         </p:txBody>
       </p:sp>
@@ -2739,7 +2739,7 @@
         </p:nvSpPr>
         <p:spPr>
           <a:xfrm>
-            <a:off x="4190695" y="2252625"/>
+            <a:off x="4106720" y="2255769"/>
             <a:ext cx="7315200" cy="1481328"/>
           </a:xfrm>
           <a:prstGeom prst="rect">
@@ -2759,7 +2759,7 @@
               <a:buNone/>
             </a:pPr>
             <a:r>
-              <a:rPr lang="en-US" sz="4000" dirty="0">
+              <a:rPr lang="en-US" sz="3600" dirty="0">
                 <a:solidFill>
                   <a:srgbClr val="333333"/>
                 </a:solidFill>
@@ -2770,7 +2770,7 @@
               <a:t>Índice de </a:t>
             </a:r>
             <a:r>
-              <a:rPr lang="en-US" sz="4000" dirty="0" err="1">
+              <a:rPr lang="en-US" sz="3600" dirty="0" err="1">
                 <a:solidFill>
                   <a:srgbClr val="333333"/>
                 </a:solidFill>
@@ -2781,7 +2781,7 @@
               <a:t>Prosperidad</a:t>
             </a:r>
             <a:r>
-              <a:rPr lang="en-US" sz="4000" dirty="0">
+              <a:rPr lang="en-US" sz="3600" dirty="0">
                 <a:solidFill>
                   <a:srgbClr val="333333"/>
                 </a:solidFill>
@@ -2789,10 +2789,10 @@
                 <a:ea typeface="Arial" pitchFamily="34" charset="-122"/>
                 <a:cs typeface="Arial" pitchFamily="34" charset="-120"/>
               </a:rPr>
-              <a:t> Andaluz. Segundo </a:t>
-            </a:r>
-            <a:r>
-              <a:rPr lang="en-US" sz="4000" dirty="0" err="1">
+              <a:t> Andaluz Segundo </a:t>
+            </a:r>
+            <a:r>
+              <a:rPr lang="en-US" sz="3600" dirty="0" err="1">
                 <a:solidFill>
                   <a:srgbClr val="333333"/>
                 </a:solidFill>
@@ -2803,7 +2803,7 @@
               <a:t>Trimestre</a:t>
             </a:r>
             <a:r>
-              <a:rPr lang="en-US" sz="4000" dirty="0">
+              <a:rPr lang="en-US" sz="3600" dirty="0">
                 <a:solidFill>
                   <a:srgbClr val="333333"/>
                 </a:solidFill>
@@ -2813,7 +2813,7 @@
               </a:rPr>
               <a:t> de 2026</a:t>
             </a:r>
-            <a:endParaRPr lang="en-US" sz="4000" dirty="0"/>
+            <a:endParaRPr lang="en-US" sz="3600" dirty="0"/>
           </a:p>
         </p:txBody>
       </p:sp>
@@ -2825,7 +2825,7 @@
         </p:nvSpPr>
         <p:spPr>
           <a:xfrm>
-            <a:off x="4190695" y="3822192"/>
+            <a:off x="5325615" y="3842010"/>
             <a:ext cx="6096305" cy="134417"/>
           </a:xfrm>
           <a:prstGeom prst="rect">
@@ -2883,7 +2883,7 @@
         </p:nvSpPr>
         <p:spPr>
           <a:xfrm>
-            <a:off x="5501889" y="4203497"/>
+            <a:off x="6326126" y="5253392"/>
             <a:ext cx="4873752" cy="822960"/>
           </a:xfrm>
           <a:prstGeom prst="rect">
@@ -2895,23 +2895,6 @@
         <p:txBody>
           <a:bodyPr wrap="square" lIns="0" tIns="0" rIns="0" bIns="0" rtlCol="0" anchor="ctr"/>
           <a:lstStyle/>
-          <a:p>
-            <a:pPr marL="0" indent="0" algn="r">
-              <a:buNone/>
-            </a:pPr>
-            <a:r>
-              <a:rPr lang="en-US" sz="3000" b="1" dirty="0">
-                <a:solidFill>
-                  <a:srgbClr val="007932"/>
-                </a:solidFill>
-                <a:latin typeface="Arial" pitchFamily="34" charset="0"/>
-                <a:ea typeface="Arial" pitchFamily="34" charset="-122"/>
-                <a:cs typeface="Arial" pitchFamily="34" charset="-120"/>
-              </a:rPr>
-              <a:t>Fundación Andalucía 27</a:t>
-            </a:r>
-            <a:endParaRPr lang="en-US" sz="3000" dirty="0"/>
-          </a:p>
           <a:p>
             <a:pPr marL="0" indent="0" algn="r">
               <a:buNone/>
@@ -2955,6 +2938,36 @@
           <a:xfrm>
             <a:off x="442632" y="928850"/>
             <a:ext cx="2553520" cy="815974"/>
+          </a:xfrm>
+          <a:prstGeom prst="rect">
+            <a:avLst/>
+          </a:prstGeom>
+        </p:spPr>
+      </p:pic>
+      <p:pic>
+        <p:nvPicPr>
+          <p:cNvPr id="13" name="Imagen 12">
+            <a:extLst>
+              <a:ext uri="{FF2B5EF4-FFF2-40B4-BE49-F238E27FC236}">
+                <a16:creationId xmlns:a16="http://schemas.microsoft.com/office/drawing/2014/main" id="{3D28BF2C-0431-93B3-C6A5-DD39C12774AF}"/>
+              </a:ext>
+            </a:extLst>
+          </p:cNvPr>
+          <p:cNvPicPr>
+            <a:picLocks noChangeAspect="1"/>
+          </p:cNvPicPr>
+          <p:nvPr/>
+        </p:nvPicPr>
+        <p:blipFill>
+          <a:blip r:embed="rId4"/>
+          <a:stretch>
+            <a:fillRect/>
+          </a:stretch>
+        </p:blipFill>
+        <p:spPr>
+          <a:xfrm>
+            <a:off x="6488326" y="4372418"/>
+            <a:ext cx="5170577" cy="986214"/>
           </a:xfrm>
           <a:prstGeom prst="rect">
             <a:avLst/>

</xml_diff>

<commit_message>
feat: actualizar rutas de guardado a results/dataYYYYMMDD y procesar ejecucion 20260904 con nuevos datos de INV_IED
</commit_message>
<xml_diff>
--- a/docs/presentaciones/presentacion_ipa27_26Q2.pptx
+++ b/docs/presentaciones/presentacion_ipa27_26Q2.pptx
@@ -7151,7 +7151,7 @@
                 <a:ea typeface="Arial" pitchFamily="34" charset="-122"/>
                 <a:cs typeface="Arial" pitchFamily="34" charset="-120"/>
               </a:rPr>
-              <a:t>caída</a:t>
+              <a:t>reducción</a:t>
             </a:r>
             <a:r>
               <a:rPr lang="en-US" sz="1500" dirty="0">
@@ -7162,7 +7162,40 @@
                 <a:ea typeface="Arial" pitchFamily="34" charset="-122"/>
                 <a:cs typeface="Arial" pitchFamily="34" charset="-120"/>
               </a:rPr>
-              <a:t> de la brecha con la media de las CCAA en </a:t>
+              <a:t> (</a:t>
+            </a:r>
+            <a:r>
+              <a:rPr lang="en-US" sz="1500" dirty="0" err="1">
+                <a:solidFill>
+                  <a:srgbClr val="000000"/>
+                </a:solidFill>
+                <a:latin typeface="Arial" pitchFamily="34" charset="0"/>
+                <a:ea typeface="Arial" pitchFamily="34" charset="-122"/>
+                <a:cs typeface="Arial" pitchFamily="34" charset="-120"/>
+              </a:rPr>
+              <a:t>mejoría</a:t>
+            </a:r>
+            <a:r>
+              <a:rPr lang="en-US" sz="1500">
+                <a:solidFill>
+                  <a:srgbClr val="000000"/>
+                </a:solidFill>
+                <a:latin typeface="Arial" pitchFamily="34" charset="0"/>
+                <a:ea typeface="Arial" pitchFamily="34" charset="-122"/>
+                <a:cs typeface="Arial" pitchFamily="34" charset="-120"/>
+              </a:rPr>
+              <a:t>) </a:t>
+            </a:r>
+            <a:r>
+              <a:rPr lang="en-US" sz="1500" dirty="0">
+                <a:solidFill>
+                  <a:srgbClr val="000000"/>
+                </a:solidFill>
+                <a:latin typeface="Arial" pitchFamily="34" charset="0"/>
+                <a:ea typeface="Arial" pitchFamily="34" charset="-122"/>
+                <a:cs typeface="Arial" pitchFamily="34" charset="-120"/>
+              </a:rPr>
+              <a:t>de la brecha con la media de las CCAA en </a:t>
             </a:r>
             <a:r>
               <a:rPr lang="en-US" sz="1500" b="1" dirty="0">
@@ -8105,6 +8138,36 @@
           </a:p>
         </p:txBody>
       </p:sp>
+      <p:pic>
+        <p:nvPicPr>
+          <p:cNvPr id="6" name="Imagen 5">
+            <a:extLst>
+              <a:ext uri="{FF2B5EF4-FFF2-40B4-BE49-F238E27FC236}">
+                <a16:creationId xmlns:a16="http://schemas.microsoft.com/office/drawing/2014/main" id="{4EADA2FB-DDC0-1C52-C831-5C11A3791307}"/>
+              </a:ext>
+            </a:extLst>
+          </p:cNvPr>
+          <p:cNvPicPr>
+            <a:picLocks noChangeAspect="1"/>
+          </p:cNvPicPr>
+          <p:nvPr/>
+        </p:nvPicPr>
+        <p:blipFill>
+          <a:blip r:embed="rId3"/>
+          <a:stretch>
+            <a:fillRect/>
+          </a:stretch>
+        </p:blipFill>
+        <p:spPr>
+          <a:xfrm>
+            <a:off x="2031656" y="714821"/>
+            <a:ext cx="8128381" cy="1550373"/>
+          </a:xfrm>
+          <a:prstGeom prst="rect">
+            <a:avLst/>
+          </a:prstGeom>
+        </p:spPr>
+      </p:pic>
     </p:spTree>
   </p:cSld>
   <p:clrMapOvr>

</xml_diff>